<commit_message>
feat: LLM evaluation, supplementary models, updated report/deck/declarations for default-on local LLM
- Report: LLM section 8.9 with measured results, naive Bayes / MLP / k-means supplement, updated responsible-AI and limitations
- Deck, declarations, model/prompt config updated for Llama 3.2 via Ollama
- llm_eval and extra_models results, new screenshots, submission builder includes them

Co-Authored-By: Claude Sonnet 5.5 <noreply@anthropic.com>
</commit_message>
<xml_diff>
--- a/presentation/CB.SC.U4AIE23211_Presentation_v1.0.pptx
+++ b/presentation/CB.SC.U4AIE23211_Presentation_v1.0.pptx
@@ -4307,7 +4307,7 @@
                 <a:ea typeface="Calibri" pitchFamily="34" charset="-122"/>
                 <a:cs typeface="Calibri" pitchFamily="34" charset="-120"/>
               </a:rPr>
-              <a:t>cited facts, confidence, human review</a:t>
+              <a:t>local LLM (Llama 3.2) writes a cited answer; human review</a:t>
             </a:r>
             <a:endParaRPr lang="en-US" sz="1200" dirty="0"/>
           </a:p>
@@ -6670,7 +6670,7 @@
                 <a:ea typeface="Calibri" pitchFamily="34" charset="-122"/>
                 <a:cs typeface="Calibri" pitchFamily="34" charset="-120"/>
               </a:rPr>
-              <a:t>Independent hand-written questions: 89% overall, 88% of answerable ones answered. Small synthetic test sets.</a:t>
+              <a:t>Independent questions: 89% overall. Local LLM (Llama 3.2): 98% correct when used on 50 questions. Small synthetic sets.</a:t>
             </a:r>
             <a:endParaRPr lang="en-US" sz="1200" dirty="0"/>
           </a:p>
@@ -6988,7 +6988,7 @@
                 <a:ea typeface="Calibri" pitchFamily="34" charset="-122"/>
                 <a:cs typeface="Calibri" pitchFamily="34" charset="-120"/>
               </a:rPr>
-              <a:t>Local models, synthetic data only</a:t>
+              <a:t>Local models only (embeddings and LLM), synthetic data</a:t>
             </a:r>
             <a:endParaRPr lang="en-US" sz="1400" dirty="0"/>
           </a:p>
@@ -7010,6 +7010,27 @@
                 <a:cs typeface="Calibri" pitchFamily="34" charset="-120"/>
               </a:rPr>
               <a:t>Roles, project isolation, audit log</a:t>
+            </a:r>
+            <a:endParaRPr lang="en-US" sz="1400" dirty="0"/>
+          </a:p>
+          <a:p>
+            <a:pPr marL="342900" indent="-342900">
+              <a:spcAft>
+                <a:spcPts val="600"/>
+              </a:spcAft>
+              <a:buSzPct val="100000"/>
+              <a:buChar char="•"/>
+            </a:pPr>
+            <a:r>
+              <a:rPr lang="en-US" sz="1400" dirty="0">
+                <a:solidFill>
+                  <a:srgbClr val="1F2933"/>
+                </a:solidFill>
+                <a:latin typeface="Calibri" pitchFamily="34" charset="0"/>
+                <a:ea typeface="Calibri" pitchFamily="34" charset="-122"/>
+                <a:cs typeface="Calibri" pitchFamily="34" charset="-120"/>
+              </a:rPr>
+              <a:t>Guards reject unfaithful LLM wording</a:t>
             </a:r>
             <a:endParaRPr lang="en-US" sz="1400" dirty="0"/>
           </a:p>
@@ -7745,7 +7766,7 @@
                 <a:ea typeface="Calibri" pitchFamily="34" charset="-122"/>
                 <a:cs typeface="Calibri" pitchFamily="34" charset="-120"/>
               </a:rPr>
-              <a:t>Local LLM and real scans not evaluated</a:t>
+              <a:t>Small LLM can mix up roles; real scans not tested</a:t>
             </a:r>
             <a:endParaRPr lang="en-US" sz="1400" dirty="0"/>
           </a:p>
@@ -7869,7 +7890,7 @@
                 <a:ea typeface="Calibri" pitchFamily="34" charset="-122"/>
                 <a:cs typeface="Calibri" pitchFamily="34" charset="-120"/>
               </a:rPr>
-              <a:t>Evaluate a local LLM</a:t>
+              <a:t>Stricter LLM tests, larger models</a:t>
             </a:r>
             <a:endParaRPr lang="en-US" sz="1400" dirty="0"/>
           </a:p>

</xml_diff>